<commit_message>
Boubacar photo-strip carousel: sharp backdrop from the full-size Gnaly photos only, no blur
Co-Authored-By: Claude Opus 5.5 <noreply@anthropic.com>
Claude-Session: https://claude.ai/code/session_014HGzAbxBh54nuyJHG7tse8
</commit_message>
<xml_diff>
--- a/templates/posts/october/01-10-2026-thu-ig-soil-regenerators-boubacar-strip.pptx
+++ b/templates/posts/october/01-10-2026-thu-ig-soil-regenerators-boubacar-strip.pptx
@@ -4368,7 +4368,7 @@
       </p:sp>
       <p:pic>
         <p:nvPicPr>
-          <p:cNvPr id="6" name="Picture 5" descr="8774713918113555898.jpg"/>
+          <p:cNvPr id="6" name="Picture 5" descr="2684496388386551764.jpg"/>
           <p:cNvPicPr>
             <a:picLocks noChangeAspect="1"/>
           </p:cNvPicPr>
@@ -4821,7 +4821,7 @@
       </p:sp>
       <p:pic>
         <p:nvPicPr>
-          <p:cNvPr id="8" name="Picture 7" descr="5813872044477051109.jpg"/>
+          <p:cNvPr id="8" name="Picture 7" descr="3828934849167861828.jpg"/>
           <p:cNvPicPr>
             <a:picLocks noChangeAspect="1"/>
           </p:cNvPicPr>
@@ -5089,7 +5089,7 @@
       </p:sp>
       <p:pic>
         <p:nvPicPr>
-          <p:cNvPr id="6" name="Picture 5" descr="2791853666144241290.jpg"/>
+          <p:cNvPr id="6" name="Picture 5" descr="1389880029561648628.jpg"/>
           <p:cNvPicPr>
             <a:picLocks noChangeAspect="1"/>
           </p:cNvPicPr>
@@ -5455,7 +5455,7 @@
       </p:sp>
       <p:pic>
         <p:nvPicPr>
-          <p:cNvPr id="8" name="Picture 7" descr="1028711469466881816.jpg"/>
+          <p:cNvPr id="8" name="Picture 7" descr="8948497843184139549.jpg"/>
           <p:cNvPicPr>
             <a:picLocks noChangeAspect="1"/>
           </p:cNvPicPr>
@@ -5836,7 +5836,7 @@
       </p:sp>
       <p:pic>
         <p:nvPicPr>
-          <p:cNvPr id="8" name="Picture 7" descr="8670841871094716204.jpg"/>
+          <p:cNvPr id="8" name="Picture 7" descr="4581230993056540404.jpg"/>
           <p:cNvPicPr>
             <a:picLocks noChangeAspect="1"/>
           </p:cNvPicPr>
@@ -6217,7 +6217,7 @@
       </p:sp>
       <p:pic>
         <p:nvPicPr>
-          <p:cNvPr id="8" name="Picture 7" descr="4627959730211700883.jpg"/>
+          <p:cNvPr id="8" name="Picture 7" descr="9204848570311242268.jpg"/>
           <p:cNvPicPr>
             <a:picLocks noChangeAspect="1"/>
           </p:cNvPicPr>
@@ -6598,7 +6598,7 @@
       </p:sp>
       <p:pic>
         <p:nvPicPr>
-          <p:cNvPr id="8" name="Picture 7" descr="5563822141639659377.jpg"/>
+          <p:cNvPr id="8" name="Picture 7" descr="807893027528448182.jpg"/>
           <p:cNvPicPr>
             <a:picLocks noChangeAspect="1"/>
           </p:cNvPicPr>
@@ -6940,7 +6940,7 @@
       </p:sp>
       <p:pic>
         <p:nvPicPr>
-          <p:cNvPr id="8" name="Picture 7" descr="1558565086583628778.jpg"/>
+          <p:cNvPr id="8" name="Picture 7" descr="1591495406811760553.jpg"/>
           <p:cNvPicPr>
             <a:picLocks noChangeAspect="1"/>
           </p:cNvPicPr>
@@ -7321,7 +7321,7 @@
       </p:sp>
       <p:pic>
         <p:nvPicPr>
-          <p:cNvPr id="8" name="Picture 7" descr="1560944784716156340.jpg"/>
+          <p:cNvPr id="8" name="Picture 7" descr="227898513560013413.jpg"/>
           <p:cNvPicPr>
             <a:picLocks noChangeAspect="1"/>
           </p:cNvPicPr>
@@ -7663,7 +7663,7 @@
       </p:sp>
       <p:pic>
         <p:nvPicPr>
-          <p:cNvPr id="8" name="Picture 7" descr="926058465959091393.jpg"/>
+          <p:cNvPr id="8" name="Picture 7" descr="6523190951154353610.jpg"/>
           <p:cNvPicPr>
             <a:picLocks noChangeAspect="1"/>
           </p:cNvPicPr>
@@ -8044,7 +8044,7 @@
       </p:sp>
       <p:pic>
         <p:nvPicPr>
-          <p:cNvPr id="8" name="Picture 7" descr="7348197993916449906.jpg"/>
+          <p:cNvPr id="8" name="Picture 7" descr="169375197795308671.jpg"/>
           <p:cNvPicPr>
             <a:picLocks noChangeAspect="1"/>
           </p:cNvPicPr>

</xml_diff>

<commit_message>
Boubacar photo-strip carousel: split photos on four seams only, the other second photos whole on their slide
Co-Authored-By: Claude Opus 5.5 <noreply@anthropic.com>
Claude-Session: https://claude.ai/code/session_014HGzAbxBh54nuyJHG7tse8
</commit_message>
<xml_diff>
--- a/templates/posts/october/01-10-2026-thu-ig-soil-regenerators-boubacar-strip.pptx
+++ b/templates/posts/october/01-10-2026-thu-ig-soil-regenerators-boubacar-strip.pptx
@@ -4368,7 +4368,7 @@
       </p:sp>
       <p:pic>
         <p:nvPicPr>
-          <p:cNvPr id="6" name="Picture 5" descr="2684496388386551764.jpg"/>
+          <p:cNvPr id="6" name="Picture 5" descr="1688473709863099450.jpg"/>
           <p:cNvPicPr>
             <a:picLocks noChangeAspect="1"/>
           </p:cNvPicPr>
@@ -4629,7 +4629,7 @@
         </p:nvSpPr>
         <p:spPr>
           <a:xfrm>
-            <a:off x="-76200" y="3067050"/>
+            <a:off x="8715375" y="3067050"/>
             <a:ext cx="1647825" cy="4152900"/>
           </a:xfrm>
           <a:prstGeom prst="rect">
@@ -4673,7 +4673,7 @@
       </p:sp>
       <p:pic>
         <p:nvPicPr>
-          <p:cNvPr id="4" name="Picture 3" descr="tmp-two-men-at-shade-house-R.jpg"/>
+          <p:cNvPr id="4" name="Picture 3" descr="tmp-young-tree-yellow-new-leaves-L.jpg"/>
           <p:cNvPicPr>
             <a:picLocks noChangeAspect="1"/>
           </p:cNvPicPr>
@@ -4687,7 +4687,7 @@
         </p:blipFill>
         <p:spPr>
           <a:xfrm>
-            <a:off x="0" y="3143250"/>
+            <a:off x="8715375" y="3143250"/>
             <a:ext cx="1571625" cy="4000500"/>
           </a:xfrm>
           <a:prstGeom prst="rect">
@@ -4703,8 +4703,8 @@
         </p:nvSpPr>
         <p:spPr>
           <a:xfrm>
-            <a:off x="8715375" y="3067050"/>
-            <a:ext cx="1647825" cy="4152900"/>
+            <a:off x="781050" y="781050"/>
+            <a:ext cx="4629150" cy="6248400"/>
           </a:xfrm>
           <a:prstGeom prst="rect">
             <a:avLst/>
@@ -4747,7 +4747,7 @@
       </p:sp>
       <p:pic>
         <p:nvPicPr>
-          <p:cNvPr id="6" name="Picture 5" descr="tmp-young-tree-yellow-new-leaves-L.jpg"/>
+          <p:cNvPr id="6" name="Picture 5" descr="6908390319155663727.jpg"/>
           <p:cNvPicPr>
             <a:picLocks noChangeAspect="1"/>
           </p:cNvPicPr>
@@ -4761,80 +4761,6 @@
         </p:blipFill>
         <p:spPr>
           <a:xfrm>
-            <a:off x="8715375" y="3143250"/>
-            <a:ext cx="1571625" cy="4000500"/>
-          </a:xfrm>
-          <a:prstGeom prst="rect">
-            <a:avLst/>
-          </a:prstGeom>
-        </p:spPr>
-      </p:pic>
-      <p:sp>
-        <p:nvSpPr>
-          <p:cNvPr id="7" name="Rectangle 6"/>
-          <p:cNvSpPr/>
-          <p:nvPr/>
-        </p:nvSpPr>
-        <p:spPr>
-          <a:xfrm>
-            <a:off x="781050" y="781050"/>
-            <a:ext cx="4629150" cy="6248400"/>
-          </a:xfrm>
-          <a:prstGeom prst="rect">
-            <a:avLst/>
-          </a:prstGeom>
-          <a:solidFill>
-            <a:srgbClr val="FFFFFF"/>
-          </a:solidFill>
-          <a:ln>
-            <a:noFill/>
-          </a:ln>
-          <a:effectLst>
-            <a:outerShdw blurRad="228600" dist="76200" dir="5400000" algn="t" rotWithShape="0">
-              <a:srgbClr val="000000">
-                <a:alpha val="30000"/>
-              </a:srgbClr>
-            </a:outerShdw>
-          </a:effectLst>
-        </p:spPr>
-        <p:style>
-          <a:lnRef idx="1">
-            <a:schemeClr val="accent1"/>
-          </a:lnRef>
-          <a:fillRef idx="3">
-            <a:schemeClr val="accent1"/>
-          </a:fillRef>
-          <a:effectRef idx="2">
-            <a:schemeClr val="accent1"/>
-          </a:effectRef>
-          <a:fontRef idx="minor">
-            <a:schemeClr val="lt1"/>
-          </a:fontRef>
-        </p:style>
-        <p:txBody>
-          <a:bodyPr rtlCol="0" anchor="ctr"/>
-          <a:lstStyle/>
-          <a:p>
-            <a:pPr algn="ctr"/>
-          </a:p>
-        </p:txBody>
-      </p:sp>
-      <p:pic>
-        <p:nvPicPr>
-          <p:cNvPr id="8" name="Picture 7" descr="3828934849167861828.jpg"/>
-          <p:cNvPicPr>
-            <a:picLocks noChangeAspect="1"/>
-          </p:cNvPicPr>
-          <p:nvPr/>
-        </p:nvPicPr>
-        <p:blipFill>
-          <a:blip r:embed="rId6"/>
-          <a:stretch>
-            <a:fillRect/>
-          </a:stretch>
-        </p:blipFill>
-        <p:spPr>
-          <a:xfrm>
             <a:off x="857250" y="857250"/>
             <a:ext cx="4476750" cy="6096000"/>
           </a:xfrm>
@@ -4845,7 +4771,7 @@
       </p:pic>
       <p:sp>
         <p:nvSpPr>
-          <p:cNvPr id="9" name="TextBox 8"/>
+          <p:cNvPr id="7" name="TextBox 6"/>
           <p:cNvSpPr txBox="1"/>
           <p:nvPr/>
         </p:nvSpPr>
@@ -4884,7 +4810,7 @@
       </p:sp>
       <p:sp>
         <p:nvSpPr>
-          <p:cNvPr id="10" name="TextBox 9"/>
+          <p:cNvPr id="8" name="TextBox 7"/>
           <p:cNvSpPr txBox="1"/>
           <p:nvPr/>
         </p:nvSpPr>
@@ -5089,7 +5015,7 @@
       </p:sp>
       <p:pic>
         <p:nvPicPr>
-          <p:cNvPr id="6" name="Picture 5" descr="1389880029561648628.jpg"/>
+          <p:cNvPr id="6" name="Picture 5" descr="2147143340270571292.jpg"/>
           <p:cNvPicPr>
             <a:picLocks noChangeAspect="1"/>
           </p:cNvPicPr>
@@ -5337,8 +5263,8 @@
         </p:nvSpPr>
         <p:spPr>
           <a:xfrm>
-            <a:off x="8715375" y="3067050"/>
-            <a:ext cx="1647825" cy="4152900"/>
+            <a:off x="781050" y="781050"/>
+            <a:ext cx="4629150" cy="6248400"/>
           </a:xfrm>
           <a:prstGeom prst="rect">
             <a:avLst/>
@@ -5381,7 +5307,7 @@
       </p:sp>
       <p:pic>
         <p:nvPicPr>
-          <p:cNvPr id="6" name="Picture 5" descr="tmp-man-by-water-tanks-L.jpg"/>
+          <p:cNvPr id="6" name="Picture 5" descr="2788890309692441782.jpg"/>
           <p:cNvPicPr>
             <a:picLocks noChangeAspect="1"/>
           </p:cNvPicPr>
@@ -5395,8 +5321,8 @@
         </p:blipFill>
         <p:spPr>
           <a:xfrm>
-            <a:off x="8715375" y="3143250"/>
-            <a:ext cx="1571625" cy="4000500"/>
+            <a:off x="857250" y="857250"/>
+            <a:ext cx="4476750" cy="6096000"/>
           </a:xfrm>
           <a:prstGeom prst="rect">
             <a:avLst/>
@@ -5411,8 +5337,8 @@
         </p:nvSpPr>
         <p:spPr>
           <a:xfrm>
-            <a:off x="781050" y="781050"/>
-            <a:ext cx="4629150" cy="6248400"/>
+            <a:off x="6019800" y="3543300"/>
+            <a:ext cx="3486150" cy="3390900"/>
           </a:xfrm>
           <a:prstGeom prst="rect">
             <a:avLst/>
@@ -5455,7 +5381,7 @@
       </p:sp>
       <p:pic>
         <p:nvPicPr>
-          <p:cNvPr id="8" name="Picture 7" descr="8948497843184139549.jpg"/>
+          <p:cNvPr id="8" name="Picture 7" descr="4092266434971960339.jpg"/>
           <p:cNvPicPr>
             <a:picLocks noChangeAspect="1"/>
           </p:cNvPicPr>
@@ -5469,8 +5395,8 @@
         </p:blipFill>
         <p:spPr>
           <a:xfrm>
-            <a:off x="857250" y="857250"/>
-            <a:ext cx="4476750" cy="6096000"/>
+            <a:off x="6096000" y="3619500"/>
+            <a:ext cx="3333750" cy="3238500"/>
           </a:xfrm>
           <a:prstGeom prst="rect">
             <a:avLst/>
@@ -5644,8 +5570,8 @@
         </p:nvSpPr>
         <p:spPr>
           <a:xfrm>
-            <a:off x="-76200" y="3067050"/>
-            <a:ext cx="1647825" cy="4152900"/>
+            <a:off x="781050" y="781050"/>
+            <a:ext cx="4629150" cy="6248400"/>
           </a:xfrm>
           <a:prstGeom prst="rect">
             <a:avLst/>
@@ -5688,7 +5614,7 @@
       </p:sp>
       <p:pic>
         <p:nvPicPr>
-          <p:cNvPr id="4" name="Picture 3" descr="tmp-man-by-water-tanks-R.jpg"/>
+          <p:cNvPr id="4" name="Picture 3" descr="4264081900031522009.jpg"/>
           <p:cNvPicPr>
             <a:picLocks noChangeAspect="1"/>
           </p:cNvPicPr>
@@ -5702,8 +5628,8 @@
         </p:blipFill>
         <p:spPr>
           <a:xfrm>
-            <a:off x="0" y="3143250"/>
-            <a:ext cx="1571625" cy="4000500"/>
+            <a:off x="857250" y="857250"/>
+            <a:ext cx="4476750" cy="6096000"/>
           </a:xfrm>
           <a:prstGeom prst="rect">
             <a:avLst/>
@@ -5718,8 +5644,8 @@
         </p:nvSpPr>
         <p:spPr>
           <a:xfrm>
-            <a:off x="8715375" y="3067050"/>
-            <a:ext cx="1647825" cy="4152900"/>
+            <a:off x="6019800" y="2781300"/>
+            <a:ext cx="3486150" cy="3390900"/>
           </a:xfrm>
           <a:prstGeom prst="rect">
             <a:avLst/>
@@ -5762,7 +5688,7 @@
       </p:sp>
       <p:pic>
         <p:nvPicPr>
-          <p:cNvPr id="6" name="Picture 5" descr="tmp-still-biochar-kiln-smoke-73s-L.jpg"/>
+          <p:cNvPr id="6" name="Picture 5" descr="3608089192992728656.jpg"/>
           <p:cNvPicPr>
             <a:picLocks noChangeAspect="1"/>
           </p:cNvPicPr>
@@ -5776,8 +5702,8 @@
         </p:blipFill>
         <p:spPr>
           <a:xfrm>
-            <a:off x="8715375" y="3143250"/>
-            <a:ext cx="1571625" cy="4000500"/>
+            <a:off x="6096000" y="2857500"/>
+            <a:ext cx="3333750" cy="3238500"/>
           </a:xfrm>
           <a:prstGeom prst="rect">
             <a:avLst/>
@@ -5786,81 +5712,7 @@
       </p:pic>
       <p:sp>
         <p:nvSpPr>
-          <p:cNvPr id="7" name="Rectangle 6"/>
-          <p:cNvSpPr/>
-          <p:nvPr/>
-        </p:nvSpPr>
-        <p:spPr>
-          <a:xfrm>
-            <a:off x="781050" y="781050"/>
-            <a:ext cx="4629150" cy="6248400"/>
-          </a:xfrm>
-          <a:prstGeom prst="rect">
-            <a:avLst/>
-          </a:prstGeom>
-          <a:solidFill>
-            <a:srgbClr val="FFFFFF"/>
-          </a:solidFill>
-          <a:ln>
-            <a:noFill/>
-          </a:ln>
-          <a:effectLst>
-            <a:outerShdw blurRad="228600" dist="76200" dir="5400000" algn="t" rotWithShape="0">
-              <a:srgbClr val="000000">
-                <a:alpha val="30000"/>
-              </a:srgbClr>
-            </a:outerShdw>
-          </a:effectLst>
-        </p:spPr>
-        <p:style>
-          <a:lnRef idx="1">
-            <a:schemeClr val="accent1"/>
-          </a:lnRef>
-          <a:fillRef idx="3">
-            <a:schemeClr val="accent1"/>
-          </a:fillRef>
-          <a:effectRef idx="2">
-            <a:schemeClr val="accent1"/>
-          </a:effectRef>
-          <a:fontRef idx="minor">
-            <a:schemeClr val="lt1"/>
-          </a:fontRef>
-        </p:style>
-        <p:txBody>
-          <a:bodyPr rtlCol="0" anchor="ctr"/>
-          <a:lstStyle/>
-          <a:p>
-            <a:pPr algn="ctr"/>
-          </a:p>
-        </p:txBody>
-      </p:sp>
-      <p:pic>
-        <p:nvPicPr>
-          <p:cNvPr id="8" name="Picture 7" descr="4581230993056540404.jpg"/>
-          <p:cNvPicPr>
-            <a:picLocks noChangeAspect="1"/>
-          </p:cNvPicPr>
-          <p:nvPr/>
-        </p:nvPicPr>
-        <p:blipFill>
-          <a:blip r:embed="rId6"/>
-          <a:stretch>
-            <a:fillRect/>
-          </a:stretch>
-        </p:blipFill>
-        <p:spPr>
-          <a:xfrm>
-            <a:off x="857250" y="857250"/>
-            <a:ext cx="4476750" cy="6096000"/>
-          </a:xfrm>
-          <a:prstGeom prst="rect">
-            <a:avLst/>
-          </a:prstGeom>
-        </p:spPr>
-      </p:pic>
-      <p:sp>
-        <p:nvSpPr>
-          <p:cNvPr id="9" name="TextBox 8"/>
+          <p:cNvPr id="7" name="TextBox 6"/>
           <p:cNvSpPr txBox="1"/>
           <p:nvPr/>
         </p:nvSpPr>
@@ -5899,7 +5751,7 @@
       </p:sp>
       <p:sp>
         <p:nvSpPr>
-          <p:cNvPr id="10" name="TextBox 9"/>
+          <p:cNvPr id="8" name="TextBox 7"/>
           <p:cNvSpPr txBox="1"/>
           <p:nvPr/>
         </p:nvSpPr>
@@ -5938,7 +5790,7 @@
       </p:sp>
       <p:sp>
         <p:nvSpPr>
-          <p:cNvPr id="11" name="TextBox 10"/>
+          <p:cNvPr id="9" name="TextBox 8"/>
           <p:cNvSpPr txBox="1"/>
           <p:nvPr/>
         </p:nvSpPr>
@@ -6025,7 +5877,7 @@
         </p:nvSpPr>
         <p:spPr>
           <a:xfrm>
-            <a:off x="-76200" y="3067050"/>
+            <a:off x="8715375" y="3067050"/>
             <a:ext cx="1647825" cy="4152900"/>
           </a:xfrm>
           <a:prstGeom prst="rect">
@@ -6069,7 +5921,7 @@
       </p:sp>
       <p:pic>
         <p:nvPicPr>
-          <p:cNvPr id="4" name="Picture 3" descr="tmp-still-biochar-kiln-smoke-73s-R.jpg"/>
+          <p:cNvPr id="4" name="Picture 3" descr="tmp-still-biochar-charcoal-16s-L.jpg"/>
           <p:cNvPicPr>
             <a:picLocks noChangeAspect="1"/>
           </p:cNvPicPr>
@@ -6083,7 +5935,7 @@
         </p:blipFill>
         <p:spPr>
           <a:xfrm>
-            <a:off x="0" y="3143250"/>
+            <a:off x="8715375" y="3143250"/>
             <a:ext cx="1571625" cy="4000500"/>
           </a:xfrm>
           <a:prstGeom prst="rect">
@@ -6099,8 +5951,8 @@
         </p:nvSpPr>
         <p:spPr>
           <a:xfrm>
-            <a:off x="8715375" y="3067050"/>
-            <a:ext cx="1647825" cy="4152900"/>
+            <a:off x="781050" y="781050"/>
+            <a:ext cx="4629150" cy="6248400"/>
           </a:xfrm>
           <a:prstGeom prst="rect">
             <a:avLst/>
@@ -6143,7 +5995,7 @@
       </p:sp>
       <p:pic>
         <p:nvPicPr>
-          <p:cNvPr id="6" name="Picture 5" descr="tmp-still-biochar-charcoal-16s-L.jpg"/>
+          <p:cNvPr id="6" name="Picture 5" descr="932775004696200115.jpg"/>
           <p:cNvPicPr>
             <a:picLocks noChangeAspect="1"/>
           </p:cNvPicPr>
@@ -6157,80 +6009,6 @@
         </p:blipFill>
         <p:spPr>
           <a:xfrm>
-            <a:off x="8715375" y="3143250"/>
-            <a:ext cx="1571625" cy="4000500"/>
-          </a:xfrm>
-          <a:prstGeom prst="rect">
-            <a:avLst/>
-          </a:prstGeom>
-        </p:spPr>
-      </p:pic>
-      <p:sp>
-        <p:nvSpPr>
-          <p:cNvPr id="7" name="Rectangle 6"/>
-          <p:cNvSpPr/>
-          <p:nvPr/>
-        </p:nvSpPr>
-        <p:spPr>
-          <a:xfrm>
-            <a:off x="781050" y="781050"/>
-            <a:ext cx="4629150" cy="6248400"/>
-          </a:xfrm>
-          <a:prstGeom prst="rect">
-            <a:avLst/>
-          </a:prstGeom>
-          <a:solidFill>
-            <a:srgbClr val="FFFFFF"/>
-          </a:solidFill>
-          <a:ln>
-            <a:noFill/>
-          </a:ln>
-          <a:effectLst>
-            <a:outerShdw blurRad="228600" dist="76200" dir="5400000" algn="t" rotWithShape="0">
-              <a:srgbClr val="000000">
-                <a:alpha val="30000"/>
-              </a:srgbClr>
-            </a:outerShdw>
-          </a:effectLst>
-        </p:spPr>
-        <p:style>
-          <a:lnRef idx="1">
-            <a:schemeClr val="accent1"/>
-          </a:lnRef>
-          <a:fillRef idx="3">
-            <a:schemeClr val="accent1"/>
-          </a:fillRef>
-          <a:effectRef idx="2">
-            <a:schemeClr val="accent1"/>
-          </a:effectRef>
-          <a:fontRef idx="minor">
-            <a:schemeClr val="lt1"/>
-          </a:fontRef>
-        </p:style>
-        <p:txBody>
-          <a:bodyPr rtlCol="0" anchor="ctr"/>
-          <a:lstStyle/>
-          <a:p>
-            <a:pPr algn="ctr"/>
-          </a:p>
-        </p:txBody>
-      </p:sp>
-      <p:pic>
-        <p:nvPicPr>
-          <p:cNvPr id="8" name="Picture 7" descr="9204848570311242268.jpg"/>
-          <p:cNvPicPr>
-            <a:picLocks noChangeAspect="1"/>
-          </p:cNvPicPr>
-          <p:nvPr/>
-        </p:nvPicPr>
-        <p:blipFill>
-          <a:blip r:embed="rId6"/>
-          <a:stretch>
-            <a:fillRect/>
-          </a:stretch>
-        </p:blipFill>
-        <p:spPr>
-          <a:xfrm>
             <a:off x="857250" y="857250"/>
             <a:ext cx="4476750" cy="6096000"/>
           </a:xfrm>
@@ -6241,7 +6019,7 @@
       </p:pic>
       <p:sp>
         <p:nvSpPr>
-          <p:cNvPr id="9" name="TextBox 8"/>
+          <p:cNvPr id="7" name="TextBox 6"/>
           <p:cNvSpPr txBox="1"/>
           <p:nvPr/>
         </p:nvSpPr>
@@ -6280,7 +6058,7 @@
       </p:sp>
       <p:sp>
         <p:nvSpPr>
-          <p:cNvPr id="10" name="TextBox 9"/>
+          <p:cNvPr id="8" name="TextBox 7"/>
           <p:cNvSpPr txBox="1"/>
           <p:nvPr/>
         </p:nvSpPr>
@@ -6319,7 +6097,7 @@
       </p:sp>
       <p:sp>
         <p:nvSpPr>
-          <p:cNvPr id="11" name="TextBox 10"/>
+          <p:cNvPr id="9" name="TextBox 8"/>
           <p:cNvSpPr txBox="1"/>
           <p:nvPr/>
         </p:nvSpPr>
@@ -6480,8 +6258,8 @@
         </p:nvSpPr>
         <p:spPr>
           <a:xfrm>
-            <a:off x="8715375" y="3067050"/>
-            <a:ext cx="1647825" cy="4152900"/>
+            <a:off x="781050" y="781050"/>
+            <a:ext cx="4629150" cy="6248400"/>
           </a:xfrm>
           <a:prstGeom prst="rect">
             <a:avLst/>
@@ -6524,7 +6302,7 @@
       </p:sp>
       <p:pic>
         <p:nvPicPr>
-          <p:cNvPr id="6" name="Picture 5" descr="tmp-banana-bunch-L.jpg"/>
+          <p:cNvPr id="6" name="Picture 5" descr="4798261194218871868.jpg"/>
           <p:cNvPicPr>
             <a:picLocks noChangeAspect="1"/>
           </p:cNvPicPr>
@@ -6538,8 +6316,8 @@
         </p:blipFill>
         <p:spPr>
           <a:xfrm>
-            <a:off x="8715375" y="3143250"/>
-            <a:ext cx="1571625" cy="4000500"/>
+            <a:off x="857250" y="857250"/>
+            <a:ext cx="4476750" cy="6096000"/>
           </a:xfrm>
           <a:prstGeom prst="rect">
             <a:avLst/>
@@ -6554,8 +6332,8 @@
         </p:nvSpPr>
         <p:spPr>
           <a:xfrm>
-            <a:off x="781050" y="781050"/>
-            <a:ext cx="4629150" cy="6248400"/>
+            <a:off x="6019800" y="3543300"/>
+            <a:ext cx="3486150" cy="3390900"/>
           </a:xfrm>
           <a:prstGeom prst="rect">
             <a:avLst/>
@@ -6598,7 +6376,7 @@
       </p:sp>
       <p:pic>
         <p:nvPicPr>
-          <p:cNvPr id="8" name="Picture 7" descr="807893027528448182.jpg"/>
+          <p:cNvPr id="8" name="Picture 7" descr="674657978003138774.jpg"/>
           <p:cNvPicPr>
             <a:picLocks noChangeAspect="1"/>
           </p:cNvPicPr>
@@ -6612,8 +6390,8 @@
         </p:blipFill>
         <p:spPr>
           <a:xfrm>
-            <a:off x="857250" y="857250"/>
-            <a:ext cx="4476750" cy="6096000"/>
+            <a:off x="6096000" y="3619500"/>
+            <a:ext cx="3333750" cy="3238500"/>
           </a:xfrm>
           <a:prstGeom prst="rect">
             <a:avLst/>
@@ -6748,8 +6526,8 @@
         </p:nvSpPr>
         <p:spPr>
           <a:xfrm>
-            <a:off x="-76200" y="3067050"/>
-            <a:ext cx="1647825" cy="4152900"/>
+            <a:off x="781050" y="781050"/>
+            <a:ext cx="4629150" cy="6248400"/>
           </a:xfrm>
           <a:prstGeom prst="rect">
             <a:avLst/>
@@ -6792,7 +6570,7 @@
       </p:sp>
       <p:pic>
         <p:nvPicPr>
-          <p:cNvPr id="4" name="Picture 3" descr="tmp-banana-bunch-R.jpg"/>
+          <p:cNvPr id="4" name="Picture 3" descr="4650512589823211481.jpg"/>
           <p:cNvPicPr>
             <a:picLocks noChangeAspect="1"/>
           </p:cNvPicPr>
@@ -6806,8 +6584,8 @@
         </p:blipFill>
         <p:spPr>
           <a:xfrm>
-            <a:off x="0" y="3143250"/>
-            <a:ext cx="1571625" cy="4000500"/>
+            <a:off x="857250" y="857250"/>
+            <a:ext cx="4476750" cy="6096000"/>
           </a:xfrm>
           <a:prstGeom prst="rect">
             <a:avLst/>
@@ -6822,8 +6600,8 @@
         </p:nvSpPr>
         <p:spPr>
           <a:xfrm>
-            <a:off x="8715375" y="3067050"/>
-            <a:ext cx="1647825" cy="4152900"/>
+            <a:off x="6019800" y="2781300"/>
+            <a:ext cx="3486150" cy="3390900"/>
           </a:xfrm>
           <a:prstGeom prst="rect">
             <a:avLst/>
@@ -6866,7 +6644,7 @@
       </p:sp>
       <p:pic>
         <p:nvPicPr>
-          <p:cNvPr id="6" name="Picture 5" descr="tmp-barrel-brew-under-shelter-L.jpg"/>
+          <p:cNvPr id="6" name="Picture 5" descr="8965865767408077829.jpg"/>
           <p:cNvPicPr>
             <a:picLocks noChangeAspect="1"/>
           </p:cNvPicPr>
@@ -6880,8 +6658,8 @@
         </p:blipFill>
         <p:spPr>
           <a:xfrm>
-            <a:off x="8715375" y="3143250"/>
-            <a:ext cx="1571625" cy="4000500"/>
+            <a:off x="6096000" y="2857500"/>
+            <a:ext cx="3333750" cy="3238500"/>
           </a:xfrm>
           <a:prstGeom prst="rect">
             <a:avLst/>
@@ -6890,81 +6668,7 @@
       </p:pic>
       <p:sp>
         <p:nvSpPr>
-          <p:cNvPr id="7" name="Rectangle 6"/>
-          <p:cNvSpPr/>
-          <p:nvPr/>
-        </p:nvSpPr>
-        <p:spPr>
-          <a:xfrm>
-            <a:off x="781050" y="781050"/>
-            <a:ext cx="4629150" cy="6248400"/>
-          </a:xfrm>
-          <a:prstGeom prst="rect">
-            <a:avLst/>
-          </a:prstGeom>
-          <a:solidFill>
-            <a:srgbClr val="FFFFFF"/>
-          </a:solidFill>
-          <a:ln>
-            <a:noFill/>
-          </a:ln>
-          <a:effectLst>
-            <a:outerShdw blurRad="228600" dist="76200" dir="5400000" algn="t" rotWithShape="0">
-              <a:srgbClr val="000000">
-                <a:alpha val="30000"/>
-              </a:srgbClr>
-            </a:outerShdw>
-          </a:effectLst>
-        </p:spPr>
-        <p:style>
-          <a:lnRef idx="1">
-            <a:schemeClr val="accent1"/>
-          </a:lnRef>
-          <a:fillRef idx="3">
-            <a:schemeClr val="accent1"/>
-          </a:fillRef>
-          <a:effectRef idx="2">
-            <a:schemeClr val="accent1"/>
-          </a:effectRef>
-          <a:fontRef idx="minor">
-            <a:schemeClr val="lt1"/>
-          </a:fontRef>
-        </p:style>
-        <p:txBody>
-          <a:bodyPr rtlCol="0" anchor="ctr"/>
-          <a:lstStyle/>
-          <a:p>
-            <a:pPr algn="ctr"/>
-          </a:p>
-        </p:txBody>
-      </p:sp>
-      <p:pic>
-        <p:nvPicPr>
-          <p:cNvPr id="8" name="Picture 7" descr="1591495406811760553.jpg"/>
-          <p:cNvPicPr>
-            <a:picLocks noChangeAspect="1"/>
-          </p:cNvPicPr>
-          <p:nvPr/>
-        </p:nvPicPr>
-        <p:blipFill>
-          <a:blip r:embed="rId6"/>
-          <a:stretch>
-            <a:fillRect/>
-          </a:stretch>
-        </p:blipFill>
-        <p:spPr>
-          <a:xfrm>
-            <a:off x="857250" y="857250"/>
-            <a:ext cx="4476750" cy="6096000"/>
-          </a:xfrm>
-          <a:prstGeom prst="rect">
-            <a:avLst/>
-          </a:prstGeom>
-        </p:spPr>
-      </p:pic>
-      <p:sp>
-        <p:nvSpPr>
-          <p:cNvPr id="9" name="TextBox 8"/>
+          <p:cNvPr id="7" name="TextBox 6"/>
           <p:cNvSpPr txBox="1"/>
           <p:nvPr/>
         </p:nvSpPr>
@@ -7003,7 +6707,7 @@
       </p:sp>
       <p:sp>
         <p:nvSpPr>
-          <p:cNvPr id="10" name="TextBox 9"/>
+          <p:cNvPr id="8" name="TextBox 7"/>
           <p:cNvSpPr txBox="1"/>
           <p:nvPr/>
         </p:nvSpPr>
@@ -7042,7 +6746,7 @@
       </p:sp>
       <p:sp>
         <p:nvSpPr>
-          <p:cNvPr id="11" name="TextBox 10"/>
+          <p:cNvPr id="9" name="TextBox 8"/>
           <p:cNvSpPr txBox="1"/>
           <p:nvPr/>
         </p:nvSpPr>
@@ -7129,7 +6833,7 @@
         </p:nvSpPr>
         <p:spPr>
           <a:xfrm>
-            <a:off x="-76200" y="3067050"/>
+            <a:off x="8715375" y="3067050"/>
             <a:ext cx="1647825" cy="4152900"/>
           </a:xfrm>
           <a:prstGeom prst="rect">
@@ -7173,7 +6877,7 @@
       </p:sp>
       <p:pic>
         <p:nvPicPr>
-          <p:cNvPr id="4" name="Picture 3" descr="tmp-barrel-brew-under-shelter-R.jpg"/>
+          <p:cNvPr id="4" name="Picture 3" descr="tmp-boubacar-hand-compost-worm-L.jpg"/>
           <p:cNvPicPr>
             <a:picLocks noChangeAspect="1"/>
           </p:cNvPicPr>
@@ -7187,7 +6891,7 @@
         </p:blipFill>
         <p:spPr>
           <a:xfrm>
-            <a:off x="0" y="3143250"/>
+            <a:off x="8715375" y="3143250"/>
             <a:ext cx="1571625" cy="4000500"/>
           </a:xfrm>
           <a:prstGeom prst="rect">
@@ -7203,8 +6907,8 @@
         </p:nvSpPr>
         <p:spPr>
           <a:xfrm>
-            <a:off x="8715375" y="3067050"/>
-            <a:ext cx="1647825" cy="4152900"/>
+            <a:off x="781050" y="781050"/>
+            <a:ext cx="4629150" cy="6248400"/>
           </a:xfrm>
           <a:prstGeom prst="rect">
             <a:avLst/>
@@ -7247,7 +6951,7 @@
       </p:sp>
       <p:pic>
         <p:nvPicPr>
-          <p:cNvPr id="6" name="Picture 5" descr="tmp-boubacar-hand-compost-worm-L.jpg"/>
+          <p:cNvPr id="6" name="Picture 5" descr="3989406779150886834.jpg"/>
           <p:cNvPicPr>
             <a:picLocks noChangeAspect="1"/>
           </p:cNvPicPr>
@@ -7261,80 +6965,6 @@
         </p:blipFill>
         <p:spPr>
           <a:xfrm>
-            <a:off x="8715375" y="3143250"/>
-            <a:ext cx="1571625" cy="4000500"/>
-          </a:xfrm>
-          <a:prstGeom prst="rect">
-            <a:avLst/>
-          </a:prstGeom>
-        </p:spPr>
-      </p:pic>
-      <p:sp>
-        <p:nvSpPr>
-          <p:cNvPr id="7" name="Rectangle 6"/>
-          <p:cNvSpPr/>
-          <p:nvPr/>
-        </p:nvSpPr>
-        <p:spPr>
-          <a:xfrm>
-            <a:off x="781050" y="781050"/>
-            <a:ext cx="4629150" cy="6248400"/>
-          </a:xfrm>
-          <a:prstGeom prst="rect">
-            <a:avLst/>
-          </a:prstGeom>
-          <a:solidFill>
-            <a:srgbClr val="FFFFFF"/>
-          </a:solidFill>
-          <a:ln>
-            <a:noFill/>
-          </a:ln>
-          <a:effectLst>
-            <a:outerShdw blurRad="228600" dist="76200" dir="5400000" algn="t" rotWithShape="0">
-              <a:srgbClr val="000000">
-                <a:alpha val="30000"/>
-              </a:srgbClr>
-            </a:outerShdw>
-          </a:effectLst>
-        </p:spPr>
-        <p:style>
-          <a:lnRef idx="1">
-            <a:schemeClr val="accent1"/>
-          </a:lnRef>
-          <a:fillRef idx="3">
-            <a:schemeClr val="accent1"/>
-          </a:fillRef>
-          <a:effectRef idx="2">
-            <a:schemeClr val="accent1"/>
-          </a:effectRef>
-          <a:fontRef idx="minor">
-            <a:schemeClr val="lt1"/>
-          </a:fontRef>
-        </p:style>
-        <p:txBody>
-          <a:bodyPr rtlCol="0" anchor="ctr"/>
-          <a:lstStyle/>
-          <a:p>
-            <a:pPr algn="ctr"/>
-          </a:p>
-        </p:txBody>
-      </p:sp>
-      <p:pic>
-        <p:nvPicPr>
-          <p:cNvPr id="8" name="Picture 7" descr="227898513560013413.jpg"/>
-          <p:cNvPicPr>
-            <a:picLocks noChangeAspect="1"/>
-          </p:cNvPicPr>
-          <p:nvPr/>
-        </p:nvPicPr>
-        <p:blipFill>
-          <a:blip r:embed="rId6"/>
-          <a:stretch>
-            <a:fillRect/>
-          </a:stretch>
-        </p:blipFill>
-        <p:spPr>
-          <a:xfrm>
             <a:off x="857250" y="857250"/>
             <a:ext cx="4476750" cy="6096000"/>
           </a:xfrm>
@@ -7345,7 +6975,7 @@
       </p:pic>
       <p:sp>
         <p:nvSpPr>
-          <p:cNvPr id="9" name="TextBox 8"/>
+          <p:cNvPr id="7" name="TextBox 6"/>
           <p:cNvSpPr txBox="1"/>
           <p:nvPr/>
         </p:nvSpPr>
@@ -7384,7 +7014,7 @@
       </p:sp>
       <p:sp>
         <p:nvSpPr>
-          <p:cNvPr id="10" name="TextBox 9"/>
+          <p:cNvPr id="8" name="TextBox 7"/>
           <p:cNvSpPr txBox="1"/>
           <p:nvPr/>
         </p:nvSpPr>
@@ -7545,8 +7175,8 @@
         </p:nvSpPr>
         <p:spPr>
           <a:xfrm>
-            <a:off x="8715375" y="3067050"/>
-            <a:ext cx="1647825" cy="4152900"/>
+            <a:off x="781050" y="781050"/>
+            <a:ext cx="4629150" cy="6248400"/>
           </a:xfrm>
           <a:prstGeom prst="rect">
             <a:avLst/>
@@ -7589,7 +7219,7 @@
       </p:sp>
       <p:pic>
         <p:nvPicPr>
-          <p:cNvPr id="6" name="Picture 5" descr="tmp-caterpillar-on-leaf-L.jpg"/>
+          <p:cNvPr id="6" name="Picture 5" descr="3231696427630568812.jpg"/>
           <p:cNvPicPr>
             <a:picLocks noChangeAspect="1"/>
           </p:cNvPicPr>
@@ -7603,8 +7233,8 @@
         </p:blipFill>
         <p:spPr>
           <a:xfrm>
-            <a:off x="8715375" y="3143250"/>
-            <a:ext cx="1571625" cy="4000500"/>
+            <a:off x="857250" y="857250"/>
+            <a:ext cx="4476750" cy="6096000"/>
           </a:xfrm>
           <a:prstGeom prst="rect">
             <a:avLst/>
@@ -7619,8 +7249,8 @@
         </p:nvSpPr>
         <p:spPr>
           <a:xfrm>
-            <a:off x="781050" y="781050"/>
-            <a:ext cx="4629150" cy="6248400"/>
+            <a:off x="6019800" y="3543300"/>
+            <a:ext cx="3486150" cy="3390900"/>
           </a:xfrm>
           <a:prstGeom prst="rect">
             <a:avLst/>
@@ -7663,7 +7293,7 @@
       </p:sp>
       <p:pic>
         <p:nvPicPr>
-          <p:cNvPr id="8" name="Picture 7" descr="6523190951154353610.jpg"/>
+          <p:cNvPr id="8" name="Picture 7" descr="7407093126315393956.jpg"/>
           <p:cNvPicPr>
             <a:picLocks noChangeAspect="1"/>
           </p:cNvPicPr>
@@ -7677,8 +7307,8 @@
         </p:blipFill>
         <p:spPr>
           <a:xfrm>
-            <a:off x="857250" y="857250"/>
-            <a:ext cx="4476750" cy="6096000"/>
+            <a:off x="6096000" y="3619500"/>
+            <a:ext cx="3333750" cy="3238500"/>
           </a:xfrm>
           <a:prstGeom prst="rect">
             <a:avLst/>
@@ -7852,8 +7482,8 @@
         </p:nvSpPr>
         <p:spPr>
           <a:xfrm>
-            <a:off x="-76200" y="3067050"/>
-            <a:ext cx="1647825" cy="4152900"/>
+            <a:off x="781050" y="781050"/>
+            <a:ext cx="4629150" cy="6248400"/>
           </a:xfrm>
           <a:prstGeom prst="rect">
             <a:avLst/>
@@ -7896,7 +7526,7 @@
       </p:sp>
       <p:pic>
         <p:nvPicPr>
-          <p:cNvPr id="4" name="Picture 3" descr="tmp-caterpillar-on-leaf-R.jpg"/>
+          <p:cNvPr id="4" name="Picture 3" descr="5034831821523673754.jpg"/>
           <p:cNvPicPr>
             <a:picLocks noChangeAspect="1"/>
           </p:cNvPicPr>
@@ -7910,8 +7540,8 @@
         </p:blipFill>
         <p:spPr>
           <a:xfrm>
-            <a:off x="0" y="3143250"/>
-            <a:ext cx="1571625" cy="4000500"/>
+            <a:off x="857250" y="857250"/>
+            <a:ext cx="4476750" cy="6096000"/>
           </a:xfrm>
           <a:prstGeom prst="rect">
             <a:avLst/>
@@ -7926,8 +7556,8 @@
         </p:nvSpPr>
         <p:spPr>
           <a:xfrm>
-            <a:off x="8715375" y="3067050"/>
-            <a:ext cx="1647825" cy="4152900"/>
+            <a:off x="6019800" y="2781300"/>
+            <a:ext cx="3486150" cy="3390900"/>
           </a:xfrm>
           <a:prstGeom prst="rect">
             <a:avLst/>
@@ -7970,7 +7600,7 @@
       </p:sp>
       <p:pic>
         <p:nvPicPr>
-          <p:cNvPr id="6" name="Picture 5" descr="tmp-two-men-at-shade-house-L.jpg"/>
+          <p:cNvPr id="6" name="Picture 5" descr="1562652928193851819.jpg"/>
           <p:cNvPicPr>
             <a:picLocks noChangeAspect="1"/>
           </p:cNvPicPr>
@@ -7984,8 +7614,8 @@
         </p:blipFill>
         <p:spPr>
           <a:xfrm>
-            <a:off x="8715375" y="3143250"/>
-            <a:ext cx="1571625" cy="4000500"/>
+            <a:off x="6096000" y="2857500"/>
+            <a:ext cx="3333750" cy="3238500"/>
           </a:xfrm>
           <a:prstGeom prst="rect">
             <a:avLst/>
@@ -7994,81 +7624,7 @@
       </p:pic>
       <p:sp>
         <p:nvSpPr>
-          <p:cNvPr id="7" name="Rectangle 6"/>
-          <p:cNvSpPr/>
-          <p:nvPr/>
-        </p:nvSpPr>
-        <p:spPr>
-          <a:xfrm>
-            <a:off x="781050" y="781050"/>
-            <a:ext cx="4629150" cy="6248400"/>
-          </a:xfrm>
-          <a:prstGeom prst="rect">
-            <a:avLst/>
-          </a:prstGeom>
-          <a:solidFill>
-            <a:srgbClr val="FFFFFF"/>
-          </a:solidFill>
-          <a:ln>
-            <a:noFill/>
-          </a:ln>
-          <a:effectLst>
-            <a:outerShdw blurRad="228600" dist="76200" dir="5400000" algn="t" rotWithShape="0">
-              <a:srgbClr val="000000">
-                <a:alpha val="30000"/>
-              </a:srgbClr>
-            </a:outerShdw>
-          </a:effectLst>
-        </p:spPr>
-        <p:style>
-          <a:lnRef idx="1">
-            <a:schemeClr val="accent1"/>
-          </a:lnRef>
-          <a:fillRef idx="3">
-            <a:schemeClr val="accent1"/>
-          </a:fillRef>
-          <a:effectRef idx="2">
-            <a:schemeClr val="accent1"/>
-          </a:effectRef>
-          <a:fontRef idx="minor">
-            <a:schemeClr val="lt1"/>
-          </a:fontRef>
-        </p:style>
-        <p:txBody>
-          <a:bodyPr rtlCol="0" anchor="ctr"/>
-          <a:lstStyle/>
-          <a:p>
-            <a:pPr algn="ctr"/>
-          </a:p>
-        </p:txBody>
-      </p:sp>
-      <p:pic>
-        <p:nvPicPr>
-          <p:cNvPr id="8" name="Picture 7" descr="169375197795308671.jpg"/>
-          <p:cNvPicPr>
-            <a:picLocks noChangeAspect="1"/>
-          </p:cNvPicPr>
-          <p:nvPr/>
-        </p:nvPicPr>
-        <p:blipFill>
-          <a:blip r:embed="rId6"/>
-          <a:stretch>
-            <a:fillRect/>
-          </a:stretch>
-        </p:blipFill>
-        <p:spPr>
-          <a:xfrm>
-            <a:off x="857250" y="857250"/>
-            <a:ext cx="4476750" cy="6096000"/>
-          </a:xfrm>
-          <a:prstGeom prst="rect">
-            <a:avLst/>
-          </a:prstGeom>
-        </p:spPr>
-      </p:pic>
-      <p:sp>
-        <p:nvSpPr>
-          <p:cNvPr id="9" name="TextBox 8"/>
+          <p:cNvPr id="7" name="TextBox 6"/>
           <p:cNvSpPr txBox="1"/>
           <p:nvPr/>
         </p:nvSpPr>
@@ -8107,7 +7663,7 @@
       </p:sp>
       <p:sp>
         <p:nvSpPr>
-          <p:cNvPr id="10" name="TextBox 9"/>
+          <p:cNvPr id="8" name="TextBox 7"/>
           <p:cNvSpPr txBox="1"/>
           <p:nvPr/>
         </p:nvSpPr>

</xml_diff>

<commit_message>
Boubacar LinkedIn image in the photo-strip style
Co-Authored-By: Claude Opus 5.5 <noreply@anthropic.com>
Claude-Session: https://claude.ai/code/session_014HGzAbxBh54nuyJHG7tse8
</commit_message>
<xml_diff>
--- a/templates/posts/october/01-10-2026-thu-ig-soil-regenerators-boubacar-strip.pptx
+++ b/templates/posts/october/01-10-2026-thu-ig-soil-regenerators-boubacar-strip.pptx
@@ -4368,7 +4368,7 @@
       </p:sp>
       <p:pic>
         <p:nvPicPr>
-          <p:cNvPr id="6" name="Picture 5" descr="1688473709863099450.jpg"/>
+          <p:cNvPr id="6" name="Picture 5" descr="9171825195743394218.jpg"/>
           <p:cNvPicPr>
             <a:picLocks noChangeAspect="1"/>
           </p:cNvPicPr>
@@ -4747,7 +4747,7 @@
       </p:sp>
       <p:pic>
         <p:nvPicPr>
-          <p:cNvPr id="6" name="Picture 5" descr="6908390319155663727.jpg"/>
+          <p:cNvPr id="6" name="Picture 5" descr="7605437770171777571.jpg"/>
           <p:cNvPicPr>
             <a:picLocks noChangeAspect="1"/>
           </p:cNvPicPr>
@@ -5015,7 +5015,7 @@
       </p:sp>
       <p:pic>
         <p:nvPicPr>
-          <p:cNvPr id="6" name="Picture 5" descr="2147143340270571292.jpg"/>
+          <p:cNvPr id="6" name="Picture 5" descr="6533855936284479388.jpg"/>
           <p:cNvPicPr>
             <a:picLocks noChangeAspect="1"/>
           </p:cNvPicPr>
@@ -5307,7 +5307,7 @@
       </p:sp>
       <p:pic>
         <p:nvPicPr>
-          <p:cNvPr id="6" name="Picture 5" descr="2788890309692441782.jpg"/>
+          <p:cNvPr id="6" name="Picture 5" descr="8157014315561803609.jpg"/>
           <p:cNvPicPr>
             <a:picLocks noChangeAspect="1"/>
           </p:cNvPicPr>
@@ -5381,7 +5381,7 @@
       </p:sp>
       <p:pic>
         <p:nvPicPr>
-          <p:cNvPr id="8" name="Picture 7" descr="4092266434971960339.jpg"/>
+          <p:cNvPr id="8" name="Picture 7" descr="2053593043082776427.jpg"/>
           <p:cNvPicPr>
             <a:picLocks noChangeAspect="1"/>
           </p:cNvPicPr>
@@ -5614,7 +5614,7 @@
       </p:sp>
       <p:pic>
         <p:nvPicPr>
-          <p:cNvPr id="4" name="Picture 3" descr="4264081900031522009.jpg"/>
+          <p:cNvPr id="4" name="Picture 3" descr="4300302597287479426.jpg"/>
           <p:cNvPicPr>
             <a:picLocks noChangeAspect="1"/>
           </p:cNvPicPr>
@@ -5688,7 +5688,7 @@
       </p:sp>
       <p:pic>
         <p:nvPicPr>
-          <p:cNvPr id="6" name="Picture 5" descr="3608089192992728656.jpg"/>
+          <p:cNvPr id="6" name="Picture 5" descr="267082155383972495.jpg"/>
           <p:cNvPicPr>
             <a:picLocks noChangeAspect="1"/>
           </p:cNvPicPr>
@@ -5995,7 +5995,7 @@
       </p:sp>
       <p:pic>
         <p:nvPicPr>
-          <p:cNvPr id="6" name="Picture 5" descr="932775004696200115.jpg"/>
+          <p:cNvPr id="6" name="Picture 5" descr="8528264047335492254.jpg"/>
           <p:cNvPicPr>
             <a:picLocks noChangeAspect="1"/>
           </p:cNvPicPr>
@@ -6302,7 +6302,7 @@
       </p:sp>
       <p:pic>
         <p:nvPicPr>
-          <p:cNvPr id="6" name="Picture 5" descr="4798261194218871868.jpg"/>
+          <p:cNvPr id="6" name="Picture 5" descr="6256601483013951417.jpg"/>
           <p:cNvPicPr>
             <a:picLocks noChangeAspect="1"/>
           </p:cNvPicPr>
@@ -6376,7 +6376,7 @@
       </p:sp>
       <p:pic>
         <p:nvPicPr>
-          <p:cNvPr id="8" name="Picture 7" descr="674657978003138774.jpg"/>
+          <p:cNvPr id="8" name="Picture 7" descr="52470658809675061.jpg"/>
           <p:cNvPicPr>
             <a:picLocks noChangeAspect="1"/>
           </p:cNvPicPr>
@@ -6570,7 +6570,7 @@
       </p:sp>
       <p:pic>
         <p:nvPicPr>
-          <p:cNvPr id="4" name="Picture 3" descr="4650512589823211481.jpg"/>
+          <p:cNvPr id="4" name="Picture 3" descr="3172829656449517480.jpg"/>
           <p:cNvPicPr>
             <a:picLocks noChangeAspect="1"/>
           </p:cNvPicPr>
@@ -6644,7 +6644,7 @@
       </p:sp>
       <p:pic>
         <p:nvPicPr>
-          <p:cNvPr id="6" name="Picture 5" descr="8965865767408077829.jpg"/>
+          <p:cNvPr id="6" name="Picture 5" descr="8596120978891480327.jpg"/>
           <p:cNvPicPr>
             <a:picLocks noChangeAspect="1"/>
           </p:cNvPicPr>
@@ -6951,7 +6951,7 @@
       </p:sp>
       <p:pic>
         <p:nvPicPr>
-          <p:cNvPr id="6" name="Picture 5" descr="3989406779150886834.jpg"/>
+          <p:cNvPr id="6" name="Picture 5" descr="2824129928653873468.jpg"/>
           <p:cNvPicPr>
             <a:picLocks noChangeAspect="1"/>
           </p:cNvPicPr>
@@ -7219,7 +7219,7 @@
       </p:sp>
       <p:pic>
         <p:nvPicPr>
-          <p:cNvPr id="6" name="Picture 5" descr="3231696427630568812.jpg"/>
+          <p:cNvPr id="6" name="Picture 5" descr="508564539031161464.jpg"/>
           <p:cNvPicPr>
             <a:picLocks noChangeAspect="1"/>
           </p:cNvPicPr>
@@ -7293,7 +7293,7 @@
       </p:sp>
       <p:pic>
         <p:nvPicPr>
-          <p:cNvPr id="8" name="Picture 7" descr="7407093126315393956.jpg"/>
+          <p:cNvPr id="8" name="Picture 7" descr="3668474902458943473.jpg"/>
           <p:cNvPicPr>
             <a:picLocks noChangeAspect="1"/>
           </p:cNvPicPr>
@@ -7526,7 +7526,7 @@
       </p:sp>
       <p:pic>
         <p:nvPicPr>
-          <p:cNvPr id="4" name="Picture 3" descr="5034831821523673754.jpg"/>
+          <p:cNvPr id="4" name="Picture 3" descr="3414100091666201139.jpg"/>
           <p:cNvPicPr>
             <a:picLocks noChangeAspect="1"/>
           </p:cNvPicPr>
@@ -7600,7 +7600,7 @@
       </p:sp>
       <p:pic>
         <p:nvPicPr>
-          <p:cNvPr id="6" name="Picture 5" descr="1562652928193851819.jpg"/>
+          <p:cNvPr id="6" name="Picture 5" descr="7499203261264999419.jpg"/>
           <p:cNvPicPr>
             <a:picLocks noChangeAspect="1"/>
           </p:cNvPicPr>

</xml_diff>

<commit_message>
Boubacar LinkedIn image: even spacing between eyebrow, name and farm line
Co-Authored-By: Claude Opus 5.5 <noreply@anthropic.com>
Claude-Session: https://claude.ai/code/session_014HGzAbxBh54nuyJHG7tse8
</commit_message>
<xml_diff>
--- a/templates/posts/october/01-10-2026-thu-ig-soil-regenerators-boubacar-strip.pptx
+++ b/templates/posts/october/01-10-2026-thu-ig-soil-regenerators-boubacar-strip.pptx
@@ -4368,7 +4368,7 @@
       </p:sp>
       <p:pic>
         <p:nvPicPr>
-          <p:cNvPr id="6" name="Picture 5" descr="9171825195743394218.jpg"/>
+          <p:cNvPr id="6" name="Picture 5" descr="472435060564469521.jpg"/>
           <p:cNvPicPr>
             <a:picLocks noChangeAspect="1"/>
           </p:cNvPicPr>
@@ -4747,7 +4747,7 @@
       </p:sp>
       <p:pic>
         <p:nvPicPr>
-          <p:cNvPr id="6" name="Picture 5" descr="7605437770171777571.jpg"/>
+          <p:cNvPr id="6" name="Picture 5" descr="994532453684768895.jpg"/>
           <p:cNvPicPr>
             <a:picLocks noChangeAspect="1"/>
           </p:cNvPicPr>
@@ -5015,7 +5015,7 @@
       </p:sp>
       <p:pic>
         <p:nvPicPr>
-          <p:cNvPr id="6" name="Picture 5" descr="6533855936284479388.jpg"/>
+          <p:cNvPr id="6" name="Picture 5" descr="7030404637930969497.jpg"/>
           <p:cNvPicPr>
             <a:picLocks noChangeAspect="1"/>
           </p:cNvPicPr>
@@ -5307,7 +5307,7 @@
       </p:sp>
       <p:pic>
         <p:nvPicPr>
-          <p:cNvPr id="6" name="Picture 5" descr="8157014315561803609.jpg"/>
+          <p:cNvPr id="6" name="Picture 5" descr="6934014170723661219.jpg"/>
           <p:cNvPicPr>
             <a:picLocks noChangeAspect="1"/>
           </p:cNvPicPr>
@@ -5381,7 +5381,7 @@
       </p:sp>
       <p:pic>
         <p:nvPicPr>
-          <p:cNvPr id="8" name="Picture 7" descr="2053593043082776427.jpg"/>
+          <p:cNvPr id="8" name="Picture 7" descr="8323465407541681997.jpg"/>
           <p:cNvPicPr>
             <a:picLocks noChangeAspect="1"/>
           </p:cNvPicPr>
@@ -5614,7 +5614,7 @@
       </p:sp>
       <p:pic>
         <p:nvPicPr>
-          <p:cNvPr id="4" name="Picture 3" descr="4300302597287479426.jpg"/>
+          <p:cNvPr id="4" name="Picture 3" descr="6916816256905964774.jpg"/>
           <p:cNvPicPr>
             <a:picLocks noChangeAspect="1"/>
           </p:cNvPicPr>
@@ -5688,7 +5688,7 @@
       </p:sp>
       <p:pic>
         <p:nvPicPr>
-          <p:cNvPr id="6" name="Picture 5" descr="267082155383972495.jpg"/>
+          <p:cNvPr id="6" name="Picture 5" descr="201871343413110759.jpg"/>
           <p:cNvPicPr>
             <a:picLocks noChangeAspect="1"/>
           </p:cNvPicPr>
@@ -5995,7 +5995,7 @@
       </p:sp>
       <p:pic>
         <p:nvPicPr>
-          <p:cNvPr id="6" name="Picture 5" descr="8528264047335492254.jpg"/>
+          <p:cNvPr id="6" name="Picture 5" descr="8124920259103191796.jpg"/>
           <p:cNvPicPr>
             <a:picLocks noChangeAspect="1"/>
           </p:cNvPicPr>
@@ -6302,7 +6302,7 @@
       </p:sp>
       <p:pic>
         <p:nvPicPr>
-          <p:cNvPr id="6" name="Picture 5" descr="6256601483013951417.jpg"/>
+          <p:cNvPr id="6" name="Picture 5" descr="2480362690307253277.jpg"/>
           <p:cNvPicPr>
             <a:picLocks noChangeAspect="1"/>
           </p:cNvPicPr>
@@ -6376,7 +6376,7 @@
       </p:sp>
       <p:pic>
         <p:nvPicPr>
-          <p:cNvPr id="8" name="Picture 7" descr="52470658809675061.jpg"/>
+          <p:cNvPr id="8" name="Picture 7" descr="5481493263636622995.jpg"/>
           <p:cNvPicPr>
             <a:picLocks noChangeAspect="1"/>
           </p:cNvPicPr>
@@ -6570,7 +6570,7 @@
       </p:sp>
       <p:pic>
         <p:nvPicPr>
-          <p:cNvPr id="4" name="Picture 3" descr="3172829656449517480.jpg"/>
+          <p:cNvPr id="4" name="Picture 3" descr="7486342686489086607.jpg"/>
           <p:cNvPicPr>
             <a:picLocks noChangeAspect="1"/>
           </p:cNvPicPr>
@@ -6644,7 +6644,7 @@
       </p:sp>
       <p:pic>
         <p:nvPicPr>
-          <p:cNvPr id="6" name="Picture 5" descr="8596120978891480327.jpg"/>
+          <p:cNvPr id="6" name="Picture 5" descr="1172837530844731553.jpg"/>
           <p:cNvPicPr>
             <a:picLocks noChangeAspect="1"/>
           </p:cNvPicPr>
@@ -6951,7 +6951,7 @@
       </p:sp>
       <p:pic>
         <p:nvPicPr>
-          <p:cNvPr id="6" name="Picture 5" descr="2824129928653873468.jpg"/>
+          <p:cNvPr id="6" name="Picture 5" descr="11441294362683797.jpg"/>
           <p:cNvPicPr>
             <a:picLocks noChangeAspect="1"/>
           </p:cNvPicPr>
@@ -7219,7 +7219,7 @@
       </p:sp>
       <p:pic>
         <p:nvPicPr>
-          <p:cNvPr id="6" name="Picture 5" descr="508564539031161464.jpg"/>
+          <p:cNvPr id="6" name="Picture 5" descr="9152434616242053355.jpg"/>
           <p:cNvPicPr>
             <a:picLocks noChangeAspect="1"/>
           </p:cNvPicPr>
@@ -7293,7 +7293,7 @@
       </p:sp>
       <p:pic>
         <p:nvPicPr>
-          <p:cNvPr id="8" name="Picture 7" descr="3668474902458943473.jpg"/>
+          <p:cNvPr id="8" name="Picture 7" descr="5691298600063485449.jpg"/>
           <p:cNvPicPr>
             <a:picLocks noChangeAspect="1"/>
           </p:cNvPicPr>
@@ -7526,7 +7526,7 @@
       </p:sp>
       <p:pic>
         <p:nvPicPr>
-          <p:cNvPr id="4" name="Picture 3" descr="3414100091666201139.jpg"/>
+          <p:cNvPr id="4" name="Picture 3" descr="2198474856025618189.jpg"/>
           <p:cNvPicPr>
             <a:picLocks noChangeAspect="1"/>
           </p:cNvPicPr>
@@ -7600,7 +7600,7 @@
       </p:sp>
       <p:pic>
         <p:nvPicPr>
-          <p:cNvPr id="6" name="Picture 5" descr="7499203261264999419.jpg"/>
+          <p:cNvPr id="6" name="Picture 5" descr="8434805731914051859.jpg"/>
           <p:cNvPicPr>
             <a:picLocks noChangeAspect="1"/>
           </p:cNvPicPr>

</xml_diff>

<commit_message>
Boubacar photo-strip carousel: 10 slides (healthier-soil quote slide removed), backdrop and split seams rebuilt so it still reads as one panorama
Co-Authored-By: Claude Opus 5.5 <noreply@anthropic.com>
Claude-Session: https://claude.ai/code/session_014HGzAbxBh54nuyJHG7tse8
</commit_message>
<xml_diff>
--- a/templates/posts/october/01-10-2026-thu-ig-soil-regenerators-boubacar-strip.pptx
+++ b/templates/posts/october/01-10-2026-thu-ig-soil-regenerators-boubacar-strip.pptx
@@ -15,7 +15,6 @@
     <p:sldId id="263" r:id="rId15"/>
     <p:sldId id="264" r:id="rId16"/>
     <p:sldId id="265" r:id="rId17"/>
-    <p:sldId id="266" r:id="rId18"/>
   </p:sldIdLst>
   <p:sldSz cx="10287000" cy="12858750" type="screen4x3"/>
   <p:notesSz cx="6858000" cy="9144000"/>
@@ -582,76 +581,6 @@
           <a:lstStyle/>
           <a:p>
             <a:r>
-              <a:t>Photo-strip seamless carousel (after the Will Khoury reference). Backdrop assets/collage/boubacar-strip/ (his photos, flat Deep Green tint). Main photo: group-of-five-farmers.jpeg. Seam photo to next slide: young-tree-yellow-new-leaves.jpg. His words from his email to Allison, 30 Sep 2026.</a:t>
-            </a:r>
-          </a:p>
-        </p:txBody>
-      </p:sp>
-      <p:sp>
-        <p:nvSpPr>
-          <p:cNvPr id="4" name="Slide Number Placeholder 3"/>
-          <p:cNvSpPr>
-            <a:spLocks noGrp="1"/>
-          </p:cNvSpPr>
-          <p:nvPr>
-            <p:ph type="sldNum" idx="5" sz="quarter"/>
-          </p:nvPr>
-        </p:nvSpPr>
-        <p:spPr/>
-      </p:sp>
-    </p:spTree>
-  </p:cSld>
-  <p:clrMapOvr>
-    <a:masterClrMapping/>
-  </p:clrMapOvr>
-</p:notes>
-</file>
-
-<file path=ppt/notesSlides/notesSlide11.xml><?xml version="1.0" encoding="utf-8"?>
-<p:notes xmlns:a="http://schemas.openxmlformats.org/drawingml/2006/main" xmlns:p="http://schemas.openxmlformats.org/presentationml/2006/main" xmlns:r="http://schemas.openxmlformats.org/officeDocument/2006/relationships">
-  <p:cSld>
-    <p:spTree>
-      <p:nvGrpSpPr>
-        <p:cNvPr id="1" name=""/>
-        <p:cNvGrpSpPr/>
-        <p:nvPr/>
-      </p:nvGrpSpPr>
-      <p:grpSpPr>
-        <a:xfrm>
-          <a:off x="0" y="0"/>
-          <a:ext cx="0" cy="0"/>
-          <a:chOff x="0" y="0"/>
-          <a:chExt cx="0" cy="0"/>
-        </a:xfrm>
-      </p:grpSpPr>
-      <p:sp>
-        <p:nvSpPr>
-          <p:cNvPr id="2" name="Slide Image Placeholder 1"/>
-          <p:cNvSpPr>
-            <a:spLocks noGrp="1"/>
-          </p:cNvSpPr>
-          <p:nvPr>
-            <p:ph type="sldImg" idx="2"/>
-          </p:nvPr>
-        </p:nvSpPr>
-        <p:spPr/>
-      </p:sp>
-      <p:sp>
-        <p:nvSpPr>
-          <p:cNvPr id="3" name="Notes Placeholder 2"/>
-          <p:cNvSpPr>
-            <a:spLocks noGrp="1"/>
-          </p:cNvSpPr>
-          <p:nvPr>
-            <p:ph type="body" idx="3" sz="quarter"/>
-          </p:nvPr>
-        </p:nvSpPr>
-        <p:spPr/>
-        <p:txBody>
-          <a:bodyPr/>
-          <a:lstStyle/>
-          <a:p>
-            <a:r>
               <a:t>Photo-strip seamless carousel (after the Will Khoury reference). Backdrop assets/collage/boubacar-strip/ (his photos, flat Deep Green tint). Main photo: young-coffee-plant.jpg. His words from his email to Allison, 30 Sep 2026.</a:t>
             </a:r>
           </a:p>
@@ -1212,7 +1141,7 @@
           <a:lstStyle/>
           <a:p>
             <a:r>
-              <a:t>Photo-strip seamless carousel (after the Will Khoury reference). Backdrop assets/collage/boubacar-strip/ (his photos, flat Deep Green tint). Main photo: yellow-caterpillar-on-stem.jpg. Seam photo to next slide: two-men-at-shade-house.jpeg. His words from his email to Allison, 30 Sep 2026.</a:t>
+              <a:t>Photo-strip seamless carousel (after the Will Khoury reference). Backdrop assets/collage/boubacar-strip/ (his photos, flat Deep Green tint). Main photo: group-of-five-farmers.jpeg. Seam photo to next slide: young-tree-yellow-new-leaves.jpg. His words from his email to Allison, 30 Sep 2026.</a:t>
             </a:r>
           </a:p>
         </p:txBody>
@@ -4368,7 +4297,7 @@
       </p:sp>
       <p:pic>
         <p:nvPicPr>
-          <p:cNvPr id="6" name="Picture 5" descr="472435060564469521.jpg"/>
+          <p:cNvPr id="6" name="Picture 5" descr="9056309327787220979.jpg"/>
           <p:cNvPicPr>
             <a:picLocks noChangeAspect="1"/>
           </p:cNvPicPr>
@@ -4629,7 +4558,7 @@
         </p:nvSpPr>
         <p:spPr>
           <a:xfrm>
-            <a:off x="8715375" y="3067050"/>
+            <a:off x="-76200" y="3067050"/>
             <a:ext cx="1647825" cy="4152900"/>
           </a:xfrm>
           <a:prstGeom prst="rect">
@@ -4673,7 +4602,7 @@
       </p:sp>
       <p:pic>
         <p:nvPicPr>
-          <p:cNvPr id="4" name="Picture 3" descr="tmp-young-tree-yellow-new-leaves-L.jpg"/>
+          <p:cNvPr id="4" name="Picture 3" descr="tmp-young-tree-yellow-new-leaves-R.jpg"/>
           <p:cNvPicPr>
             <a:picLocks noChangeAspect="1"/>
           </p:cNvPicPr>
@@ -4687,7 +4616,7 @@
         </p:blipFill>
         <p:spPr>
           <a:xfrm>
-            <a:off x="8715375" y="3143250"/>
+            <a:off x="0" y="3143250"/>
             <a:ext cx="1571625" cy="4000500"/>
           </a:xfrm>
           <a:prstGeom prst="rect">
@@ -4747,275 +4676,7 @@
       </p:sp>
       <p:pic>
         <p:nvPicPr>
-          <p:cNvPr id="6" name="Picture 5" descr="994532453684768895.jpg"/>
-          <p:cNvPicPr>
-            <a:picLocks noChangeAspect="1"/>
-          </p:cNvPicPr>
-          <p:nvPr/>
-        </p:nvPicPr>
-        <p:blipFill>
-          <a:blip r:embed="rId5"/>
-          <a:stretch>
-            <a:fillRect/>
-          </a:stretch>
-        </p:blipFill>
-        <p:spPr>
-          <a:xfrm>
-            <a:off x="857250" y="857250"/>
-            <a:ext cx="4476750" cy="6096000"/>
-          </a:xfrm>
-          <a:prstGeom prst="rect">
-            <a:avLst/>
-          </a:prstGeom>
-        </p:spPr>
-      </p:pic>
-      <p:sp>
-        <p:nvSpPr>
-          <p:cNvPr id="7" name="TextBox 6"/>
-          <p:cNvSpPr txBox="1"/>
-          <p:nvPr/>
-        </p:nvSpPr>
-        <p:spPr>
-          <a:xfrm>
-            <a:off x="762000" y="8620125"/>
-            <a:ext cx="8763000" cy="2248265"/>
-          </a:xfrm>
-          <a:prstGeom prst="rect">
-            <a:avLst/>
-          </a:prstGeom>
-          <a:noFill/>
-        </p:spPr>
-        <p:txBody>
-          <a:bodyPr wrap="square" lIns="0" rIns="0" tIns="0" bIns="0" anchor="t">
-            <a:spAutoFit/>
-          </a:bodyPr>
-          <a:lstStyle/>
-          <a:p>
-            <a:pPr algn="l">
-              <a:lnSpc>
-                <a:spcPct val="115000"/>
-              </a:lnSpc>
-            </a:pPr>
-            <a:r>
-              <a:rPr sz="4200" b="0" i="1">
-                <a:solidFill>
-                  <a:srgbClr val="111111"/>
-                </a:solidFill>
-                <a:latin typeface="EB Garamond"/>
-              </a:rPr>
-              <a:t>“Your training changed the way I see agriculture. I now believe that agriculture is biology, not chemical fertilizer.”</a:t>
-            </a:r>
-          </a:p>
-        </p:txBody>
-      </p:sp>
-      <p:sp>
-        <p:nvSpPr>
-          <p:cNvPr id="8" name="TextBox 7"/>
-          <p:cNvSpPr txBox="1"/>
-          <p:nvPr/>
-        </p:nvSpPr>
-        <p:spPr>
-          <a:xfrm>
-            <a:off x="0" y="12096750"/>
-            <a:ext cx="10287000" cy="419100"/>
-          </a:xfrm>
-          <a:prstGeom prst="rect">
-            <a:avLst/>
-          </a:prstGeom>
-          <a:noFill/>
-        </p:spPr>
-        <p:txBody>
-          <a:bodyPr wrap="square" lIns="0" rIns="0" tIns="0" bIns="0" anchor="ctr">
-            <a:spAutoFit/>
-          </a:bodyPr>
-          <a:lstStyle/>
-          <a:p>
-            <a:pPr algn="ctr">
-              <a:lnSpc>
-                <a:spcPct val="120000"/>
-              </a:lnSpc>
-            </a:pPr>
-            <a:r>
-              <a:rPr sz="2200" b="1" i="0">
-                <a:solidFill>
-                  <a:srgbClr val="4C3634"/>
-                </a:solidFill>
-                <a:latin typeface="Montserrat"/>
-              </a:rPr>
-              <a:t>soilfoodweb.com</a:t>
-            </a:r>
-          </a:p>
-        </p:txBody>
-      </p:sp>
-    </p:spTree>
-  </p:cSld>
-  <p:clrMapOvr>
-    <a:masterClrMapping/>
-  </p:clrMapOvr>
-</p:sld>
-</file>
-
-<file path=ppt/slides/slide11.xml><?xml version="1.0" encoding="utf-8"?>
-<p:sld xmlns:a="http://schemas.openxmlformats.org/drawingml/2006/main" xmlns:p="http://schemas.openxmlformats.org/presentationml/2006/main" xmlns:r="http://schemas.openxmlformats.org/officeDocument/2006/relationships">
-  <p:cSld>
-    <p:spTree>
-      <p:nvGrpSpPr>
-        <p:cNvPr id="1" name=""/>
-        <p:cNvGrpSpPr/>
-        <p:nvPr/>
-      </p:nvGrpSpPr>
-      <p:grpSpPr/>
-      <p:pic>
-        <p:nvPicPr>
-          <p:cNvPr id="2" name="Picture 1" descr="slide-11.jpg"/>
-          <p:cNvPicPr>
-            <a:picLocks noChangeAspect="1"/>
-          </p:cNvPicPr>
-          <p:nvPr/>
-        </p:nvPicPr>
-        <p:blipFill>
-          <a:blip r:embed="rId3"/>
-          <a:stretch>
-            <a:fillRect/>
-          </a:stretch>
-        </p:blipFill>
-        <p:spPr>
-          <a:xfrm>
-            <a:off x="0" y="0"/>
-            <a:ext cx="10287000" cy="12858750"/>
-          </a:xfrm>
-          <a:prstGeom prst="rect">
-            <a:avLst/>
-          </a:prstGeom>
-        </p:spPr>
-      </p:pic>
-      <p:sp>
-        <p:nvSpPr>
-          <p:cNvPr id="3" name="Rectangle 2"/>
-          <p:cNvSpPr/>
-          <p:nvPr/>
-        </p:nvSpPr>
-        <p:spPr>
-          <a:xfrm>
-            <a:off x="-76200" y="3067050"/>
-            <a:ext cx="1647825" cy="4152900"/>
-          </a:xfrm>
-          <a:prstGeom prst="rect">
-            <a:avLst/>
-          </a:prstGeom>
-          <a:solidFill>
-            <a:srgbClr val="FFFFFF"/>
-          </a:solidFill>
-          <a:ln>
-            <a:noFill/>
-          </a:ln>
-          <a:effectLst>
-            <a:outerShdw blurRad="228600" dist="76200" dir="5400000" algn="t" rotWithShape="0">
-              <a:srgbClr val="000000">
-                <a:alpha val="30000"/>
-              </a:srgbClr>
-            </a:outerShdw>
-          </a:effectLst>
-        </p:spPr>
-        <p:style>
-          <a:lnRef idx="1">
-            <a:schemeClr val="accent1"/>
-          </a:lnRef>
-          <a:fillRef idx="3">
-            <a:schemeClr val="accent1"/>
-          </a:fillRef>
-          <a:effectRef idx="2">
-            <a:schemeClr val="accent1"/>
-          </a:effectRef>
-          <a:fontRef idx="minor">
-            <a:schemeClr val="lt1"/>
-          </a:fontRef>
-        </p:style>
-        <p:txBody>
-          <a:bodyPr rtlCol="0" anchor="ctr"/>
-          <a:lstStyle/>
-          <a:p>
-            <a:pPr algn="ctr"/>
-          </a:p>
-        </p:txBody>
-      </p:sp>
-      <p:pic>
-        <p:nvPicPr>
-          <p:cNvPr id="4" name="Picture 3" descr="tmp-young-tree-yellow-new-leaves-R.jpg"/>
-          <p:cNvPicPr>
-            <a:picLocks noChangeAspect="1"/>
-          </p:cNvPicPr>
-          <p:nvPr/>
-        </p:nvPicPr>
-        <p:blipFill>
-          <a:blip r:embed="rId4"/>
-          <a:stretch>
-            <a:fillRect/>
-          </a:stretch>
-        </p:blipFill>
-        <p:spPr>
-          <a:xfrm>
-            <a:off x="0" y="3143250"/>
-            <a:ext cx="1571625" cy="4000500"/>
-          </a:xfrm>
-          <a:prstGeom prst="rect">
-            <a:avLst/>
-          </a:prstGeom>
-        </p:spPr>
-      </p:pic>
-      <p:sp>
-        <p:nvSpPr>
-          <p:cNvPr id="5" name="Rectangle 4"/>
-          <p:cNvSpPr/>
-          <p:nvPr/>
-        </p:nvSpPr>
-        <p:spPr>
-          <a:xfrm>
-            <a:off x="781050" y="781050"/>
-            <a:ext cx="4629150" cy="6248400"/>
-          </a:xfrm>
-          <a:prstGeom prst="rect">
-            <a:avLst/>
-          </a:prstGeom>
-          <a:solidFill>
-            <a:srgbClr val="FFFFFF"/>
-          </a:solidFill>
-          <a:ln>
-            <a:noFill/>
-          </a:ln>
-          <a:effectLst>
-            <a:outerShdw blurRad="228600" dist="76200" dir="5400000" algn="t" rotWithShape="0">
-              <a:srgbClr val="000000">
-                <a:alpha val="30000"/>
-              </a:srgbClr>
-            </a:outerShdw>
-          </a:effectLst>
-        </p:spPr>
-        <p:style>
-          <a:lnRef idx="1">
-            <a:schemeClr val="accent1"/>
-          </a:lnRef>
-          <a:fillRef idx="3">
-            <a:schemeClr val="accent1"/>
-          </a:fillRef>
-          <a:effectRef idx="2">
-            <a:schemeClr val="accent1"/>
-          </a:effectRef>
-          <a:fontRef idx="minor">
-            <a:schemeClr val="lt1"/>
-          </a:fontRef>
-        </p:style>
-        <p:txBody>
-          <a:bodyPr rtlCol="0" anchor="ctr"/>
-          <a:lstStyle/>
-          <a:p>
-            <a:pPr algn="ctr"/>
-          </a:p>
-        </p:txBody>
-      </p:sp>
-      <p:pic>
-        <p:nvPicPr>
-          <p:cNvPr id="6" name="Picture 5" descr="7030404637930969497.jpg"/>
+          <p:cNvPr id="6" name="Picture 5" descr="4057219912471011073.jpg"/>
           <p:cNvPicPr>
             <a:picLocks noChangeAspect="1"/>
           </p:cNvPicPr>
@@ -5307,7 +4968,7 @@
       </p:sp>
       <p:pic>
         <p:nvPicPr>
-          <p:cNvPr id="6" name="Picture 5" descr="6934014170723661219.jpg"/>
+          <p:cNvPr id="6" name="Picture 5" descr="453331874453259988.jpg"/>
           <p:cNvPicPr>
             <a:picLocks noChangeAspect="1"/>
           </p:cNvPicPr>
@@ -5381,7 +5042,7 @@
       </p:sp>
       <p:pic>
         <p:nvPicPr>
-          <p:cNvPr id="8" name="Picture 7" descr="8323465407541681997.jpg"/>
+          <p:cNvPr id="8" name="Picture 7" descr="9023643621668367224.jpg"/>
           <p:cNvPicPr>
             <a:picLocks noChangeAspect="1"/>
           </p:cNvPicPr>
@@ -5614,7 +5275,7 @@
       </p:sp>
       <p:pic>
         <p:nvPicPr>
-          <p:cNvPr id="4" name="Picture 3" descr="6916816256905964774.jpg"/>
+          <p:cNvPr id="4" name="Picture 3" descr="4933932451574522546.jpg"/>
           <p:cNvPicPr>
             <a:picLocks noChangeAspect="1"/>
           </p:cNvPicPr>
@@ -5688,7 +5349,7 @@
       </p:sp>
       <p:pic>
         <p:nvPicPr>
-          <p:cNvPr id="6" name="Picture 5" descr="201871343413110759.jpg"/>
+          <p:cNvPr id="6" name="Picture 5" descr="7197361783543646948.jpg"/>
           <p:cNvPicPr>
             <a:picLocks noChangeAspect="1"/>
           </p:cNvPicPr>
@@ -5995,7 +5656,7 @@
       </p:sp>
       <p:pic>
         <p:nvPicPr>
-          <p:cNvPr id="6" name="Picture 5" descr="8124920259103191796.jpg"/>
+          <p:cNvPr id="6" name="Picture 5" descr="5795035781961691268.jpg"/>
           <p:cNvPicPr>
             <a:picLocks noChangeAspect="1"/>
           </p:cNvPicPr>
@@ -6302,7 +5963,7 @@
       </p:sp>
       <p:pic>
         <p:nvPicPr>
-          <p:cNvPr id="6" name="Picture 5" descr="2480362690307253277.jpg"/>
+          <p:cNvPr id="6" name="Picture 5" descr="4739107852276681341.jpg"/>
           <p:cNvPicPr>
             <a:picLocks noChangeAspect="1"/>
           </p:cNvPicPr>
@@ -6376,7 +6037,7 @@
       </p:sp>
       <p:pic>
         <p:nvPicPr>
-          <p:cNvPr id="8" name="Picture 7" descr="5481493263636622995.jpg"/>
+          <p:cNvPr id="8" name="Picture 7" descr="5521767497666000470.jpg"/>
           <p:cNvPicPr>
             <a:picLocks noChangeAspect="1"/>
           </p:cNvPicPr>
@@ -6570,7 +6231,7 @@
       </p:sp>
       <p:pic>
         <p:nvPicPr>
-          <p:cNvPr id="4" name="Picture 3" descr="7486342686489086607.jpg"/>
+          <p:cNvPr id="4" name="Picture 3" descr="1100706642336658112.jpg"/>
           <p:cNvPicPr>
             <a:picLocks noChangeAspect="1"/>
           </p:cNvPicPr>
@@ -6644,7 +6305,7 @@
       </p:sp>
       <p:pic>
         <p:nvPicPr>
-          <p:cNvPr id="6" name="Picture 5" descr="1172837530844731553.jpg"/>
+          <p:cNvPr id="6" name="Picture 5" descr="4582573813895461234.jpg"/>
           <p:cNvPicPr>
             <a:picLocks noChangeAspect="1"/>
           </p:cNvPicPr>
@@ -6951,7 +6612,7 @@
       </p:sp>
       <p:pic>
         <p:nvPicPr>
-          <p:cNvPr id="6" name="Picture 5" descr="11441294362683797.jpg"/>
+          <p:cNvPr id="6" name="Picture 5" descr="5032125500654405990.jpg"/>
           <p:cNvPicPr>
             <a:picLocks noChangeAspect="1"/>
           </p:cNvPicPr>
@@ -7219,7 +6880,7 @@
       </p:sp>
       <p:pic>
         <p:nvPicPr>
-          <p:cNvPr id="6" name="Picture 5" descr="9152434616242053355.jpg"/>
+          <p:cNvPr id="6" name="Picture 5" descr="7557225846128720850.jpg"/>
           <p:cNvPicPr>
             <a:picLocks noChangeAspect="1"/>
           </p:cNvPicPr>
@@ -7293,7 +6954,7 @@
       </p:sp>
       <p:pic>
         <p:nvPicPr>
-          <p:cNvPr id="8" name="Picture 7" descr="5691298600063485449.jpg"/>
+          <p:cNvPr id="8" name="Picture 7" descr="6406940253850066954.jpg"/>
           <p:cNvPicPr>
             <a:picLocks noChangeAspect="1"/>
           </p:cNvPicPr>
@@ -7452,7 +7113,7 @@
       <p:grpSpPr/>
       <p:pic>
         <p:nvPicPr>
-          <p:cNvPr id="2" name="Picture 1" descr="slide-09.jpg"/>
+          <p:cNvPr id="2" name="Picture 1" descr="slide-01.jpg"/>
           <p:cNvPicPr>
             <a:picLocks noChangeAspect="1"/>
           </p:cNvPicPr>
@@ -7482,8 +7143,8 @@
         </p:nvSpPr>
         <p:spPr>
           <a:xfrm>
-            <a:off x="781050" y="781050"/>
-            <a:ext cx="4629150" cy="6248400"/>
+            <a:off x="8715375" y="3067050"/>
+            <a:ext cx="1647825" cy="4152900"/>
           </a:xfrm>
           <a:prstGeom prst="rect">
             <a:avLst/>
@@ -7526,7 +7187,7 @@
       </p:sp>
       <p:pic>
         <p:nvPicPr>
-          <p:cNvPr id="4" name="Picture 3" descr="2198474856025618189.jpg"/>
+          <p:cNvPr id="4" name="Picture 3" descr="tmp-young-tree-yellow-new-leaves-L.jpg"/>
           <p:cNvPicPr>
             <a:picLocks noChangeAspect="1"/>
           </p:cNvPicPr>
@@ -7540,8 +7201,8 @@
         </p:blipFill>
         <p:spPr>
           <a:xfrm>
-            <a:off x="857250" y="857250"/>
-            <a:ext cx="4476750" cy="6096000"/>
+            <a:off x="8715375" y="3143250"/>
+            <a:ext cx="1571625" cy="4000500"/>
           </a:xfrm>
           <a:prstGeom prst="rect">
             <a:avLst/>
@@ -7556,8 +7217,8 @@
         </p:nvSpPr>
         <p:spPr>
           <a:xfrm>
-            <a:off x="6019800" y="2781300"/>
-            <a:ext cx="3486150" cy="3390900"/>
+            <a:off x="781050" y="781050"/>
+            <a:ext cx="4629150" cy="6248400"/>
           </a:xfrm>
           <a:prstGeom prst="rect">
             <a:avLst/>
@@ -7600,7 +7261,7 @@
       </p:sp>
       <p:pic>
         <p:nvPicPr>
-          <p:cNvPr id="6" name="Picture 5" descr="8434805731914051859.jpg"/>
+          <p:cNvPr id="6" name="Picture 5" descr="1419452912463550851.jpg"/>
           <p:cNvPicPr>
             <a:picLocks noChangeAspect="1"/>
           </p:cNvPicPr>
@@ -7614,8 +7275,8 @@
         </p:blipFill>
         <p:spPr>
           <a:xfrm>
-            <a:off x="6096000" y="2857500"/>
-            <a:ext cx="3333750" cy="3238500"/>
+            <a:off x="857250" y="857250"/>
+            <a:ext cx="4476750" cy="6096000"/>
           </a:xfrm>
           <a:prstGeom prst="rect">
             <a:avLst/>
@@ -7656,7 +7317,7 @@
                 </a:solidFill>
                 <a:latin typeface="EB Garamond"/>
               </a:rPr>
-              <a:t>“I can already see signs of healthier soil in the field, including more earthworms, mushrooms, and active decomposition.”</a:t>
+              <a:t>“Your training changed the way I see agriculture. I now believe that agriculture is biology, not chemical fertilizer.”</a:t>
             </a:r>
           </a:p>
         </p:txBody>

</xml_diff>